<commit_message>
Make supervisor deck result and measured boundary clear on first slide
</commit_message>
<xml_diff>
--- a/experiments/t4-boundary-router-2026-10-05/docs/linear_attention_supervisor_review.pptx
+++ b/experiments/t4-boundary-router-2026-10-05/docs/linear_attention_supervisor_review.pptx
@@ -520,17 +520,7 @@
           <a:lstStyle/>
           <a:p>
             <a:r>
-              <a:t>Supervisor review. No claim of a new successful model accelerator. All measurements are taken from repository CSVs; no data generated for this deck.</a:t>
-            </a:r>
-          </a:p>
-          <a:p>
-            <a:r>
-              <a:t>Source snapshot: 8096d83526f4d134778e438484fc02a5ff1f2af7. Repository: https://github.com/Jaiadithya71/linear-attention-benchmark</a:t>
-            </a:r>
-          </a:p>
-          <a:p>
-            <a:r>
-              <a:t>Tesla T4 experiments | 5 October 2026 | Jaiadithya A</a:t>
+              <a:t>Plain-language verdict. Basic and detailed speed claims are different cohorts. Basic: efficiency.csv method linear/sdpa, dtype fp32, N65536, noncausal. Retrieval: retrieval.csv fp32 beta64 N4096 trials300. Detailed synthetic: scaling.csv one-shot speedup aggregated as in make_router_detailed_report.py, N8192/32768/65536. Median crossover is not a universal safe-length boundary, and timing does not establish accuracy. Detailed Qwen: matched qwen_quality.csv/qwen_prefill.csv context2048 quality, N1024..8192 timing. Drift: scaling_heads.csv nonempty cache_target, rank&gt;0, unit-scale target, n1346. Rare-query/full-query errors: scaling_heads.csv validation_scope all_query_rows. Source snapshot8096d83526f4d134778e438484fc02a5ff1f2af7. Original source repository https://github.com/Jaiadithya71/linear-attention-benchmark. No measurements rerun. Supporting detail follows.</a:t>
             </a:r>
           </a:p>
         </p:txBody>
@@ -4965,14 +4955,14 @@
           <a:noFill/>
         </p:spPr>
         <p:txBody>
-          <a:bodyPr wrap="square" lIns="18288" rIns="18288" tIns="18288" bIns="18288">
+          <a:bodyPr wrap="square" lIns="27432" rIns="27432" tIns="18288" bIns="18288">
             <a:spAutoFit/>
           </a:bodyPr>
           <a:lstStyle/>
           <a:p>
             <a:pPr>
               <a:spcAft>
-                <a:spcPts val="1000"/>
+                <a:spcPts val="400"/>
               </a:spcAft>
               <a:defRPr sz="1000" b="1">
                 <a:solidFill>
@@ -4996,7 +4986,7 @@
         <p:spPr>
           <a:xfrm>
             <a:off x="457200" y="585216"/>
-            <a:ext cx="11247120" cy="694944"/>
+            <a:ext cx="11247120" cy="731520"/>
           </a:xfrm>
           <a:prstGeom prst="rect">
             <a:avLst/>
@@ -5004,16 +4994,16 @@
           <a:noFill/>
         </p:spPr>
         <p:txBody>
-          <a:bodyPr wrap="square" lIns="18288" rIns="18288" tIns="18288" bIns="18288">
+          <a:bodyPr wrap="square" lIns="27432" rIns="27432" tIns="18288" bIns="18288">
             <a:spAutoFit/>
           </a:bodyPr>
           <a:lstStyle/>
           <a:p>
             <a:pPr>
               <a:spcAft>
-                <a:spcPts val="1000"/>
-              </a:spcAft>
-              <a:defRPr sz="3000" b="0">
+                <a:spcPts val="400"/>
+              </a:spcAft>
+              <a:defRPr sz="2800" b="0">
                 <a:solidFill>
                   <a:srgbClr val="251F21"/>
                 </a:solidFill>
@@ -5021,7 +5011,7 @@
               </a:defRPr>
             </a:pPr>
             <a:r>
-              <a:t>Where linear attention stops being a safe substitute</a:t>
+              <a:t>Result: faster synthetic tests, no real-model speedup</a:t>
             </a:r>
           </a:p>
         </p:txBody>
@@ -5034,8 +5024,8 @@
         </p:nvSpPr>
         <p:spPr>
           <a:xfrm>
-            <a:off x="457200" y="1298448"/>
-            <a:ext cx="11155680" cy="502920"/>
+            <a:off x="502920" y="1417320"/>
+            <a:ext cx="11155680" cy="566928"/>
           </a:xfrm>
           <a:prstGeom prst="rect">
             <a:avLst/>
@@ -5043,16 +5033,16 @@
           <a:noFill/>
         </p:spPr>
         <p:txBody>
-          <a:bodyPr wrap="square" lIns="18288" rIns="18288" tIns="18288" bIns="18288">
+          <a:bodyPr wrap="square" lIns="27432" rIns="27432" tIns="18288" bIns="18288">
             <a:spAutoFit/>
           </a:bodyPr>
           <a:lstStyle/>
           <a:p>
             <a:pPr>
               <a:spcAft>
-                <a:spcPts val="1000"/>
-              </a:spcAft>
-              <a:defRPr sz="1700" b="0">
+                <a:spcPts val="400"/>
+              </a:spcAft>
+              <a:defRPr sz="1900" b="0">
                 <a:solidFill>
                   <a:srgbClr val="585254"/>
                 </a:solidFill>
@@ -5060,7 +5050,7 @@
               </a:defRPr>
             </a:pPr>
             <a:r>
-              <a:t>Measured boundary + a negative adaptive-router result</a:t>
+              <a:t>We tried replacing exact attention with cheaper summaries, then routing only when error looked small.</a:t>
             </a:r>
           </a:p>
         </p:txBody>
@@ -5073,14 +5063,14 @@
         </p:nvSpPr>
         <p:spPr>
           <a:xfrm>
-            <a:off x="457200" y="6419088"/>
-            <a:ext cx="11247120" cy="10972"/>
+            <a:off x="548640" y="2103120"/>
+            <a:ext cx="11064240" cy="841248"/>
           </a:xfrm>
           <a:prstGeom prst="rect">
             <a:avLst/>
           </a:prstGeom>
           <a:solidFill>
-            <a:srgbClr val="EAE9EA"/>
+            <a:srgbClr val="F4EFEC"/>
           </a:solidFill>
           <a:ln>
             <a:noFill/>
@@ -5116,8 +5106,8 @@
         </p:nvSpPr>
         <p:spPr>
           <a:xfrm>
-            <a:off x="457200" y="6510528"/>
-            <a:ext cx="10789920" cy="210312"/>
+            <a:off x="713232" y="2221991"/>
+            <a:ext cx="2240280" cy="566928"/>
           </a:xfrm>
           <a:prstGeom prst="rect">
             <a:avLst/>
@@ -5125,24 +5115,24 @@
           <a:noFill/>
         </p:spPr>
         <p:txBody>
-          <a:bodyPr wrap="square" lIns="18288" rIns="18288" tIns="18288" bIns="18288">
+          <a:bodyPr wrap="square" lIns="27432" rIns="27432" tIns="18288" bIns="18288">
             <a:spAutoFit/>
           </a:bodyPr>
           <a:lstStyle/>
           <a:p>
             <a:pPr>
               <a:spcAft>
-                <a:spcPts val="1000"/>
-              </a:spcAft>
-              <a:defRPr sz="900" b="0">
-                <a:solidFill>
-                  <a:srgbClr val="585254"/>
-                </a:solidFill>
-                <a:latin typeface="Arial"/>
-              </a:defRPr>
-            </a:pPr>
-            <a:r>
-              <a:t>Tesla T4 experiments | 5 October 2026 | Jaiadithya A</a:t>
+                <a:spcPts val="400"/>
+              </a:spcAft>
+              <a:defRPr sz="1700" b="1">
+                <a:solidFill>
+                  <a:srgbClr val="35796D"/>
+                </a:solidFill>
+                <a:latin typeface="Arial"/>
+              </a:defRPr>
+            </a:pPr>
+            <a:r>
+              <a:t>WHAT WORKED</a:t>
             </a:r>
           </a:p>
         </p:txBody>
@@ -5155,8 +5145,8 @@
         </p:nvSpPr>
         <p:spPr>
           <a:xfrm>
-            <a:off x="11247120" y="6492240"/>
-            <a:ext cx="457200" cy="228600"/>
+            <a:off x="2980944" y="2194560"/>
+            <a:ext cx="8366760" cy="685800"/>
           </a:xfrm>
           <a:prstGeom prst="rect">
             <a:avLst/>
@@ -5164,93 +5154,54 @@
           <a:noFill/>
         </p:spPr>
         <p:txBody>
-          <a:bodyPr wrap="square" lIns="18288" rIns="18288" tIns="18288" bIns="18288">
+          <a:bodyPr wrap="square" lIns="27432" rIns="27432" tIns="18288" bIns="18288">
             <a:spAutoFit/>
           </a:bodyPr>
           <a:lstStyle/>
           <a:p>
             <a:pPr>
               <a:spcAft>
-                <a:spcPts val="1000"/>
-              </a:spcAft>
-              <a:defRPr sz="1000" b="0">
-                <a:solidFill>
-                  <a:srgbClr val="585254"/>
-                </a:solidFill>
-                <a:latin typeface="Arial"/>
-              </a:defRPr>
-            </a:pPr>
-            <a:r>
-              <a:t>01</a:t>
-            </a:r>
-          </a:p>
-        </p:txBody>
-      </p:sp>
-      <p:sp>
-        <p:nvSpPr>
-          <p:cNvPr id="8" name="TextBox 7"/>
-          <p:cNvSpPr txBox="1"/>
-          <p:nvPr/>
-        </p:nvSpPr>
-        <p:spPr>
-          <a:xfrm>
-            <a:off x="594360" y="2011680"/>
-            <a:ext cx="10789920" cy="1371600"/>
-          </a:xfrm>
-          <a:prstGeom prst="rect">
-            <a:avLst/>
-          </a:prstGeom>
-          <a:noFill/>
-        </p:spPr>
-        <p:txBody>
-          <a:bodyPr wrap="square" lIns="18288" rIns="18288" tIns="18288" bIns="18288">
-            <a:spAutoFit/>
-          </a:bodyPr>
-          <a:lstStyle/>
-          <a:p>
-            <a:pPr>
-              <a:spcAft>
-                <a:spcPts val="1000"/>
-              </a:spcAft>
-              <a:defRPr sz="3700" b="0">
+                <a:spcPts val="400"/>
+              </a:spcAft>
+              <a:defRPr sz="1700" b="0">
                 <a:solidFill>
                   <a:srgbClr val="251F21"/>
                 </a:solidFill>
-                <a:latin typeface="Georgia"/>
-              </a:defRPr>
-            </a:pPr>
-            <a:r>
-              <a:t>Cheaper attention is possible.</a:t>
-            </a:r>
-          </a:p>
-          <a:p>
-            <a:pPr>
-              <a:spcAft>
-                <a:spcPts val="1000"/>
-              </a:spcAft>
-              <a:defRPr sz="3700" b="0">
+                <a:latin typeface="Arial"/>
+              </a:defRPr>
+            </a:pPr>
+            <a:r>
+              <a:t>Basic linear attention was much faster on long synthetic inputs.</a:t>
+            </a:r>
+          </a:p>
+          <a:p>
+            <a:pPr>
+              <a:spcAft>
+                <a:spcPts val="400"/>
+              </a:spcAft>
+              <a:defRPr sz="1700" b="0">
                 <a:solidFill>
                   <a:srgbClr val="251F21"/>
                 </a:solidFill>
-                <a:latin typeface="Georgia"/>
-              </a:defRPr>
-            </a:pPr>
-            <a:r>
-              <a:t>Safe replacement is input-dependent.</a:t>
-            </a:r>
-          </a:p>
-        </p:txBody>
-      </p:sp>
-      <p:sp>
-        <p:nvSpPr>
-          <p:cNvPr id="9" name="Rectangle 8"/>
+                <a:latin typeface="Arial"/>
+              </a:defRPr>
+            </a:pPr>
+            <a:r>
+              <a:t>At 65,536 tokens: 15.1 ms vs 3,446 ms for exact SDPA (fp32).</a:t>
+            </a:r>
+          </a:p>
+        </p:txBody>
+      </p:sp>
+      <p:sp>
+        <p:nvSpPr>
+          <p:cNvPr id="8" name="Rectangle 7"/>
           <p:cNvSpPr/>
           <p:nvPr/>
         </p:nvSpPr>
         <p:spPr>
           <a:xfrm>
-            <a:off x="594360" y="3886200"/>
-            <a:ext cx="5303520" cy="1810512"/>
+            <a:off x="548640" y="3044952"/>
+            <a:ext cx="11064240" cy="841248"/>
           </a:xfrm>
           <a:prstGeom prst="rect">
             <a:avLst/>
@@ -5286,14 +5237,53 @@
       </p:sp>
       <p:sp>
         <p:nvSpPr>
+          <p:cNvPr id="9" name="TextBox 8"/>
+          <p:cNvSpPr txBox="1"/>
+          <p:nvPr/>
+        </p:nvSpPr>
+        <p:spPr>
+          <a:xfrm>
+            <a:off x="713232" y="3163824"/>
+            <a:ext cx="2240280" cy="566928"/>
+          </a:xfrm>
+          <a:prstGeom prst="rect">
+            <a:avLst/>
+          </a:prstGeom>
+          <a:noFill/>
+        </p:spPr>
+        <p:txBody>
+          <a:bodyPr wrap="square" lIns="27432" rIns="27432" tIns="18288" bIns="18288">
+            <a:spAutoFit/>
+          </a:bodyPr>
+          <a:lstStyle/>
+          <a:p>
+            <a:pPr>
+              <a:spcAft>
+                <a:spcPts val="400"/>
+              </a:spcAft>
+              <a:defRPr sz="1700" b="1">
+                <a:solidFill>
+                  <a:srgbClr val="35796D"/>
+                </a:solidFill>
+                <a:latin typeface="Arial"/>
+              </a:defRPr>
+            </a:pPr>
+            <a:r>
+              <a:t>WHAT FAILED</a:t>
+            </a:r>
+          </a:p>
+        </p:txBody>
+      </p:sp>
+      <p:sp>
+        <p:nvSpPr>
           <p:cNvPr id="10" name="TextBox 9"/>
           <p:cNvSpPr txBox="1"/>
           <p:nvPr/>
         </p:nvSpPr>
         <p:spPr>
           <a:xfrm>
-            <a:off x="795528" y="4050791"/>
-            <a:ext cx="4901183" cy="457200"/>
+            <a:off x="2980944" y="3136392"/>
+            <a:ext cx="8366760" cy="685800"/>
           </a:xfrm>
           <a:prstGeom prst="rect">
             <a:avLst/>
@@ -5301,55 +5291,16 @@
           <a:noFill/>
         </p:spPr>
         <p:txBody>
-          <a:bodyPr wrap="square" lIns="18288" rIns="18288" tIns="18288" bIns="18288">
+          <a:bodyPr wrap="square" lIns="27432" rIns="27432" tIns="18288" bIns="18288">
             <a:spAutoFit/>
           </a:bodyPr>
           <a:lstStyle/>
           <a:p>
             <a:pPr>
               <a:spcAft>
-                <a:spcPts val="1000"/>
-              </a:spcAft>
-              <a:defRPr sz="2200" b="1">
-                <a:solidFill>
-                  <a:srgbClr val="35796D"/>
-                </a:solidFill>
-                <a:latin typeface="Arial"/>
-              </a:defRPr>
-            </a:pPr>
-            <a:r>
-              <a:t>Synthetic opportunity</a:t>
-            </a:r>
-          </a:p>
-        </p:txBody>
-      </p:sp>
-      <p:sp>
-        <p:nvSpPr>
-          <p:cNvPr id="11" name="TextBox 10"/>
-          <p:cNvSpPr txBox="1"/>
-          <p:nvPr/>
-        </p:nvSpPr>
-        <p:spPr>
-          <a:xfrm>
-            <a:off x="795528" y="4672584"/>
-            <a:ext cx="4901183" cy="896112"/>
-          </a:xfrm>
-          <a:prstGeom prst="rect">
-            <a:avLst/>
-          </a:prstGeom>
-          <a:noFill/>
-        </p:spPr>
-        <p:txBody>
-          <a:bodyPr wrap="square" lIns="18288" rIns="18288" tIns="18288" bIns="18288">
-            <a:spAutoFit/>
-          </a:bodyPr>
-          <a:lstStyle/>
-          <a:p>
-            <a:pPr>
-              <a:spcAft>
-                <a:spcPts val="1000"/>
-              </a:spcAft>
-              <a:defRPr sz="1900" b="0">
+                <a:spcPts val="400"/>
+              </a:spcAft>
+              <a:defRPr sz="1700" b="0">
                 <a:solidFill>
                   <a:srgbClr val="251F21"/>
                 </a:solidFill>
@@ -5357,21 +5308,37 @@
               </a:defRPr>
             </a:pPr>
             <a:r>
-              <a:t>Long inputs can benefit when their attention is easy to approximate.</a:t>
-            </a:r>
-          </a:p>
-        </p:txBody>
-      </p:sp>
-      <p:sp>
-        <p:nvSpPr>
-          <p:cNvPr id="12" name="Rectangle 11"/>
+              <a:t>Precise lookup: linear found 0/300 matches at 4,096 tokens (fp32, beta=64).</a:t>
+            </a:r>
+          </a:p>
+          <a:p>
+            <a:pPr>
+              <a:spcAft>
+                <a:spcPts val="400"/>
+              </a:spcAft>
+              <a:defRPr sz="1700" b="0">
+                <a:solidFill>
+                  <a:srgbClr val="251F21"/>
+                </a:solidFill>
+                <a:latin typeface="Arial"/>
+              </a:defRPr>
+            </a:pPr>
+            <a:r>
+              <a:t>Qwen router: slower at every tested length, with no joint speed-and-quality win.</a:t>
+            </a:r>
+          </a:p>
+        </p:txBody>
+      </p:sp>
+      <p:sp>
+        <p:nvSpPr>
+          <p:cNvPr id="11" name="Rectangle 10"/>
           <p:cNvSpPr/>
           <p:nvPr/>
         </p:nvSpPr>
         <p:spPr>
           <a:xfrm>
-            <a:off x="6126480" y="3886200"/>
-            <a:ext cx="5440680" cy="1810512"/>
+            <a:off x="548640" y="3986783"/>
+            <a:ext cx="11064240" cy="841248"/>
           </a:xfrm>
           <a:prstGeom prst="rect">
             <a:avLst/>
@@ -5407,14 +5374,53 @@
       </p:sp>
       <p:sp>
         <p:nvSpPr>
+          <p:cNvPr id="12" name="TextBox 11"/>
+          <p:cNvSpPr txBox="1"/>
+          <p:nvPr/>
+        </p:nvSpPr>
+        <p:spPr>
+          <a:xfrm>
+            <a:off x="713232" y="4105655"/>
+            <a:ext cx="2240280" cy="566928"/>
+          </a:xfrm>
+          <a:prstGeom prst="rect">
+            <a:avLst/>
+          </a:prstGeom>
+          <a:noFill/>
+        </p:spPr>
+        <p:txBody>
+          <a:bodyPr wrap="square" lIns="27432" rIns="27432" tIns="18288" bIns="18288">
+            <a:spAutoFit/>
+          </a:bodyPr>
+          <a:lstStyle/>
+          <a:p>
+            <a:pPr>
+              <a:spcAft>
+                <a:spcPts val="400"/>
+              </a:spcAft>
+              <a:defRPr sz="1700" b="1">
+                <a:solidFill>
+                  <a:srgbClr val="35796D"/>
+                </a:solidFill>
+                <a:latin typeface="Arial"/>
+              </a:defRPr>
+            </a:pPr>
+            <a:r>
+              <a:t>MEASURED BOUNDARY</a:t>
+            </a:r>
+          </a:p>
+        </p:txBody>
+      </p:sp>
+      <p:sp>
+        <p:nvSpPr>
           <p:cNvPr id="13" name="TextBox 12"/>
           <p:cNvSpPr txBox="1"/>
           <p:nvPr/>
         </p:nvSpPr>
         <p:spPr>
           <a:xfrm>
-            <a:off x="6327648" y="4050791"/>
-            <a:ext cx="5038344" cy="457200"/>
+            <a:off x="2980944" y="4078223"/>
+            <a:ext cx="8366760" cy="685800"/>
           </a:xfrm>
           <a:prstGeom prst="rect">
             <a:avLst/>
@@ -5422,38 +5428,97 @@
           <a:noFill/>
         </p:spPr>
         <p:txBody>
-          <a:bodyPr wrap="square" lIns="18288" rIns="18288" tIns="18288" bIns="18288">
+          <a:bodyPr wrap="square" lIns="27432" rIns="27432" tIns="18288" bIns="18288">
             <a:spAutoFit/>
           </a:bodyPr>
           <a:lstStyle/>
           <a:p>
             <a:pPr>
               <a:spcAft>
-                <a:spcPts val="1000"/>
-              </a:spcAft>
-              <a:defRPr sz="2200" b="1">
-                <a:solidFill>
-                  <a:srgbClr val="35796D"/>
-                </a:solidFill>
-                <a:latin typeface="Arial"/>
-              </a:defRPr>
-            </a:pPr>
-            <a:r>
-              <a:t>Real-model outcome</a:t>
-            </a:r>
-          </a:p>
-        </p:txBody>
-      </p:sp>
-      <p:sp>
-        <p:nvSpPr>
-          <p:cNvPr id="14" name="TextBox 13"/>
+                <a:spcPts val="400"/>
+              </a:spcAft>
+              <a:defRPr sz="1700" b="0">
+                <a:solidFill>
+                  <a:srgbClr val="251F21"/>
+                </a:solidFill>
+                <a:latin typeface="Arial"/>
+              </a:defRPr>
+            </a:pPr>
+            <a:r>
+              <a:t>One-shot router median speedup: 0.486x at 8k, 1.725x at 32k, 3.558x at 65,536.</a:t>
+            </a:r>
+          </a:p>
+          <a:p>
+            <a:pPr>
+              <a:spcAft>
+                <a:spcPts val="400"/>
+              </a:spcAft>
+              <a:defRPr sz="1700" b="0">
+                <a:solidFill>
+                  <a:srgbClr val="251F21"/>
+                </a:solidFill>
+                <a:latin typeface="Arial"/>
+              </a:defRPr>
+            </a:pPr>
+            <a:r>
+              <a:t>This is across synthetic test cells, not a universal cutoff or a Qwen forecast.</a:t>
+            </a:r>
+          </a:p>
+        </p:txBody>
+      </p:sp>
+      <p:sp>
+        <p:nvSpPr>
+          <p:cNvPr id="14" name="Rectangle 13"/>
+          <p:cNvSpPr/>
+          <p:nvPr/>
+        </p:nvSpPr>
+        <p:spPr>
+          <a:xfrm>
+            <a:off x="548640" y="4928616"/>
+            <a:ext cx="11064240" cy="841248"/>
+          </a:xfrm>
+          <a:prstGeom prst="rect">
+            <a:avLst/>
+          </a:prstGeom>
+          <a:solidFill>
+            <a:srgbClr val="F4EFEC"/>
+          </a:solidFill>
+          <a:ln>
+            <a:noFill/>
+          </a:ln>
+        </p:spPr>
+        <p:style>
+          <a:lnRef idx="1">
+            <a:schemeClr val="accent1"/>
+          </a:lnRef>
+          <a:fillRef idx="3">
+            <a:schemeClr val="accent1"/>
+          </a:fillRef>
+          <a:effectRef idx="2">
+            <a:schemeClr val="accent1"/>
+          </a:effectRef>
+          <a:fontRef idx="minor">
+            <a:schemeClr val="lt1"/>
+          </a:fontRef>
+        </p:style>
+        <p:txBody>
+          <a:bodyPr rtlCol="0" anchor="ctr"/>
+          <a:lstStyle/>
+          <a:p>
+            <a:pPr algn="ctr"/>
+          </a:p>
+        </p:txBody>
+      </p:sp>
+      <p:sp>
+        <p:nvSpPr>
+          <p:cNvPr id="15" name="TextBox 14"/>
           <p:cNvSpPr txBox="1"/>
           <p:nvPr/>
         </p:nvSpPr>
         <p:spPr>
           <a:xfrm>
-            <a:off x="6327648" y="4672584"/>
-            <a:ext cx="5038344" cy="896112"/>
+            <a:off x="713232" y="5047488"/>
+            <a:ext cx="2240280" cy="566928"/>
           </a:xfrm>
           <a:prstGeom prst="rect">
             <a:avLst/>
@@ -5461,16 +5526,55 @@
           <a:noFill/>
         </p:spPr>
         <p:txBody>
-          <a:bodyPr wrap="square" lIns="18288" rIns="18288" tIns="18288" bIns="18288">
+          <a:bodyPr wrap="square" lIns="27432" rIns="27432" tIns="18288" bIns="18288">
             <a:spAutoFit/>
           </a:bodyPr>
           <a:lstStyle/>
           <a:p>
             <a:pPr>
               <a:spcAft>
-                <a:spcPts val="1000"/>
-              </a:spcAft>
-              <a:defRPr sz="1900" b="0">
+                <a:spcPts val="400"/>
+              </a:spcAft>
+              <a:defRPr sz="1700" b="1">
+                <a:solidFill>
+                  <a:srgbClr val="35796D"/>
+                </a:solidFill>
+                <a:latin typeface="Arial"/>
+              </a:defRPr>
+            </a:pPr>
+            <a:r>
+              <a:t>SAFETY LIMIT</a:t>
+            </a:r>
+          </a:p>
+        </p:txBody>
+      </p:sp>
+      <p:sp>
+        <p:nvSpPr>
+          <p:cNvPr id="16" name="TextBox 15"/>
+          <p:cNvSpPr txBox="1"/>
+          <p:nvPr/>
+        </p:nvSpPr>
+        <p:spPr>
+          <a:xfrm>
+            <a:off x="2980944" y="5020055"/>
+            <a:ext cx="8366760" cy="685800"/>
+          </a:xfrm>
+          <a:prstGeom prst="rect">
+            <a:avLst/>
+          </a:prstGeom>
+          <a:noFill/>
+        </p:spPr>
+        <p:txBody>
+          <a:bodyPr wrap="square" lIns="27432" rIns="27432" tIns="18288" bIns="18288">
+            <a:spAutoFit/>
+          </a:bodyPr>
+          <a:lstStyle/>
+          <a:p>
+            <a:pPr>
+              <a:spcAft>
+                <a:spcPts val="400"/>
+              </a:spcAft>
+              <a:defRPr sz="1700" b="0">
                 <a:solidFill>
                   <a:srgbClr val="251F21"/>
                 </a:solidFill>
@@ -5478,7 +5582,183 @@
               </a:defRPr>
             </a:pPr>
             <a:r>
-              <a:t>The tested router does not accelerate Qwen2.5-0.5B at measured lengths.</a:t>
+              <a:t>A small sampled average error missed rare bad queries.</a:t>
+            </a:r>
+          </a:p>
+          <a:p>
+            <a:pPr>
+              <a:spcAft>
+                <a:spcPts val="400"/>
+              </a:spcAft>
+              <a:defRPr sz="1700" b="0">
+                <a:solidFill>
+                  <a:srgbClr val="251F21"/>
+                </a:solidFill>
+                <a:latin typeface="Arial"/>
+              </a:defRPr>
+            </a:pPr>
+            <a:r>
+              <a:t>Reusing ranks under unit-scale drift failed in all 1,346 tested reused-linear heads.</a:t>
+            </a:r>
+          </a:p>
+        </p:txBody>
+      </p:sp>
+      <p:sp>
+        <p:nvSpPr>
+          <p:cNvPr id="17" name="TextBox 16"/>
+          <p:cNvSpPr txBox="1"/>
+          <p:nvPr/>
+        </p:nvSpPr>
+        <p:spPr>
+          <a:xfrm>
+            <a:off x="594360" y="5989320"/>
+            <a:ext cx="10972800" cy="320040"/>
+          </a:xfrm>
+          <a:prstGeom prst="rect">
+            <a:avLst/>
+          </a:prstGeom>
+          <a:noFill/>
+        </p:spPr>
+        <p:txBody>
+          <a:bodyPr wrap="square" lIns="27432" rIns="27432" tIns="18288" bIns="18288">
+            <a:spAutoFit/>
+          </a:bodyPr>
+          <a:lstStyle/>
+          <a:p>
+            <a:pPr>
+              <a:spcAft>
+                <a:spcPts val="400"/>
+              </a:spcAft>
+              <a:defRPr sz="2100" b="1">
+                <a:solidFill>
+                  <a:srgbClr val="35796D"/>
+                </a:solidFill>
+                <a:latin typeface="Arial"/>
+              </a:defRPr>
+            </a:pPr>
+            <a:r>
+              <a:t>Conclusion: useful benchmark boundary, not a safe Qwen accelerator.</a:t>
+            </a:r>
+          </a:p>
+        </p:txBody>
+      </p:sp>
+      <p:sp>
+        <p:nvSpPr>
+          <p:cNvPr id="18" name="Rectangle 17"/>
+          <p:cNvSpPr/>
+          <p:nvPr/>
+        </p:nvSpPr>
+        <p:spPr>
+          <a:xfrm>
+            <a:off x="457200" y="6419088"/>
+            <a:ext cx="11247120" cy="10972"/>
+          </a:xfrm>
+          <a:prstGeom prst="rect">
+            <a:avLst/>
+          </a:prstGeom>
+          <a:solidFill>
+            <a:srgbClr val="EAE9EA"/>
+          </a:solidFill>
+          <a:ln>
+            <a:noFill/>
+          </a:ln>
+        </p:spPr>
+        <p:style>
+          <a:lnRef idx="1">
+            <a:schemeClr val="accent1"/>
+          </a:lnRef>
+          <a:fillRef idx="3">
+            <a:schemeClr val="accent1"/>
+          </a:fillRef>
+          <a:effectRef idx="2">
+            <a:schemeClr val="accent1"/>
+          </a:effectRef>
+          <a:fontRef idx="minor">
+            <a:schemeClr val="lt1"/>
+          </a:fontRef>
+        </p:style>
+        <p:txBody>
+          <a:bodyPr rtlCol="0" anchor="ctr"/>
+          <a:lstStyle/>
+          <a:p>
+            <a:pPr algn="ctr"/>
+          </a:p>
+        </p:txBody>
+      </p:sp>
+      <p:sp>
+        <p:nvSpPr>
+          <p:cNvPr id="19" name="TextBox 18"/>
+          <p:cNvSpPr txBox="1"/>
+          <p:nvPr/>
+        </p:nvSpPr>
+        <p:spPr>
+          <a:xfrm>
+            <a:off x="457200" y="6510528"/>
+            <a:ext cx="10789920" cy="210312"/>
+          </a:xfrm>
+          <a:prstGeom prst="rect">
+            <a:avLst/>
+          </a:prstGeom>
+          <a:noFill/>
+        </p:spPr>
+        <p:txBody>
+          <a:bodyPr wrap="square" lIns="27432" rIns="27432" tIns="18288" bIns="18288">
+            <a:spAutoFit/>
+          </a:bodyPr>
+          <a:lstStyle/>
+          <a:p>
+            <a:pPr>
+              <a:spcAft>
+                <a:spcPts val="400"/>
+              </a:spcAft>
+              <a:defRPr sz="900" b="0">
+                <a:solidFill>
+                  <a:srgbClr val="585254"/>
+                </a:solidFill>
+                <a:latin typeface="Arial"/>
+              </a:defRPr>
+            </a:pPr>
+            <a:r>
+              <a:t>CSV sources: efficiency; retrieval; router_detailed/scaling, scaling_heads; router_detailed_qwen</a:t>
+            </a:r>
+          </a:p>
+        </p:txBody>
+      </p:sp>
+      <p:sp>
+        <p:nvSpPr>
+          <p:cNvPr id="20" name="TextBox 19"/>
+          <p:cNvSpPr txBox="1"/>
+          <p:nvPr/>
+        </p:nvSpPr>
+        <p:spPr>
+          <a:xfrm>
+            <a:off x="11247120" y="6492240"/>
+            <a:ext cx="457200" cy="228600"/>
+          </a:xfrm>
+          <a:prstGeom prst="rect">
+            <a:avLst/>
+          </a:prstGeom>
+          <a:noFill/>
+        </p:spPr>
+        <p:txBody>
+          <a:bodyPr wrap="square" lIns="27432" rIns="27432" tIns="18288" bIns="18288">
+            <a:spAutoFit/>
+          </a:bodyPr>
+          <a:lstStyle/>
+          <a:p>
+            <a:pPr>
+              <a:spcAft>
+                <a:spcPts val="400"/>
+              </a:spcAft>
+              <a:defRPr sz="1000" b="0">
+                <a:solidFill>
+                  <a:srgbClr val="585254"/>
+                </a:solidFill>
+                <a:latin typeface="Arial"/>
+              </a:defRPr>
+            </a:pPr>
+            <a:r>
+              <a:t>01</a:t>
             </a:r>
           </a:p>
         </p:txBody>

</xml_diff>